<commit_message>
Add the report as a one-slide annex
Slide 17, after the close: a screenshot of the recommendation page, what the four
pages are, and links to the repository and to the eight-page PDF.

One slide rather than the eight report pages. Slides 4 to 12 already carry the
report's findings redrawn for a room, so appending the pages would repeat the same
numbers in a second visual language, and the deck would end on screenshots instead of
on what the analysis does and does not prove. This answers "can I see the tool"
without re-arguing the case, and it sits after the close so the argument still ends
where it should.

77 tests pass.
Co-Authored-By: Claude Opus 5 <noreply@anthropic.com>
</commit_message>
<xml_diff>
--- a/MPG_PeopleAnalytics_Executive.pptx
+++ b/MPG_PeopleAnalytics_Executive.pptx
@@ -21,6 +21,7 @@
     <p:sldId id="269" r:id="rId21"/>
     <p:sldId id="270" r:id="rId22"/>
     <p:sldId id="271" r:id="rId23"/>
+    <p:sldId id="272" r:id="rId24"/>
   </p:sldIdLst>
   <p:sldSz cx="12191695" cy="6858000" type="screen4x3"/>
   <p:notesSz cx="6858000" cy="9144000"/>
@@ -1278,6 +1279,76 @@
           <a:p>
             <a:r>
               <a:t>The recommendation is not to spend less for its own sake. It is that the blanket proposal spends where the evidence is not.</a:t>
+            </a:r>
+          </a:p>
+        </p:txBody>
+      </p:sp>
+      <p:sp>
+        <p:nvSpPr>
+          <p:cNvPr id="4" name="Slide Number Placeholder 3"/>
+          <p:cNvSpPr>
+            <a:spLocks noGrp="1"/>
+          </p:cNvSpPr>
+          <p:nvPr>
+            <p:ph type="sldNum" idx="5" sz="quarter"/>
+          </p:nvPr>
+        </p:nvSpPr>
+        <p:spPr/>
+      </p:sp>
+    </p:spTree>
+  </p:cSld>
+  <p:clrMapOvr>
+    <a:masterClrMapping/>
+  </p:clrMapOvr>
+</p:notes>
+</file>
+
+<file path=ppt/notesSlides/notesSlide2.xml><?xml version="1.0" encoding="utf-8"?>
+<p:notes xmlns:a="http://schemas.openxmlformats.org/drawingml/2006/main" xmlns:p="http://schemas.openxmlformats.org/presentationml/2006/main" xmlns:r="http://schemas.openxmlformats.org/officeDocument/2006/relationships">
+  <p:cSld>
+    <p:spTree>
+      <p:nvGrpSpPr>
+        <p:cNvPr id="1" name=""/>
+        <p:cNvGrpSpPr/>
+        <p:nvPr/>
+      </p:nvGrpSpPr>
+      <p:grpSpPr>
+        <a:xfrm>
+          <a:off x="0" y="0"/>
+          <a:ext cx="0" cy="0"/>
+          <a:chOff x="0" y="0"/>
+          <a:chExt cx="0" cy="0"/>
+        </a:xfrm>
+      </p:grpSpPr>
+      <p:sp>
+        <p:nvSpPr>
+          <p:cNvPr id="2" name="Slide Image Placeholder 1"/>
+          <p:cNvSpPr>
+            <a:spLocks noGrp="1"/>
+          </p:cNvSpPr>
+          <p:nvPr>
+            <p:ph type="sldImg" idx="2"/>
+          </p:nvPr>
+        </p:nvSpPr>
+        <p:spPr/>
+      </p:sp>
+      <p:sp>
+        <p:nvSpPr>
+          <p:cNvPr id="3" name="Notes Placeholder 2"/>
+          <p:cNvSpPr>
+            <a:spLocks noGrp="1"/>
+          </p:cNvSpPr>
+          <p:nvPr>
+            <p:ph type="body" idx="3" sz="quarter"/>
+          </p:nvPr>
+        </p:nvSpPr>
+        <p:spPr/>
+        <p:txBody>
+          <a:bodyPr/>
+          <a:lstStyle/>
+          <a:p>
+            <a:r>
+              <a:t>Annex. Not part of the argument - it exists so anyone who wants to see the tool behind the numbers can reach it.</a:t>
             </a:r>
           </a:p>
         </p:txBody>
@@ -8787,6 +8858,293 @@
                 <a:latin typeface="Calibri"/>
               </a:rPr>
               <a:t>And it is why the recommendation is a pilot rather than a rollout.</a:t>
+            </a:r>
+          </a:p>
+        </p:txBody>
+      </p:sp>
+    </p:spTree>
+  </p:cSld>
+  <p:clrMapOvr>
+    <a:masterClrMapping/>
+  </p:clrMapOvr>
+</p:sld>
+</file>
+
+<file path=ppt/slides/slide17.xml><?xml version="1.0" encoding="utf-8"?>
+<p:sld xmlns:a="http://schemas.openxmlformats.org/drawingml/2006/main" xmlns:p="http://schemas.openxmlformats.org/presentationml/2006/main" xmlns:r="http://schemas.openxmlformats.org/officeDocument/2006/relationships">
+  <p:cSld>
+    <p:spTree>
+      <p:nvGrpSpPr>
+        <p:cNvPr id="1" name=""/>
+        <p:cNvGrpSpPr/>
+        <p:nvPr/>
+      </p:nvGrpSpPr>
+      <p:grpSpPr/>
+      <p:sp>
+        <p:nvSpPr>
+          <p:cNvPr id="2" name="Rectangle 1"/>
+          <p:cNvSpPr/>
+          <p:nvPr/>
+        </p:nvSpPr>
+        <p:spPr>
+          <a:xfrm>
+            <a:off x="0" y="0"/>
+            <a:ext cx="12191695" cy="6858000"/>
+          </a:xfrm>
+          <a:prstGeom prst="rect">
+            <a:avLst/>
+          </a:prstGeom>
+          <a:solidFill>
+            <a:srgbClr val="F2F4F7"/>
+          </a:solidFill>
+          <a:ln>
+            <a:noFill/>
+          </a:ln>
+          <a:effectLst/>
+        </p:spPr>
+        <p:style>
+          <a:lnRef idx="1">
+            <a:schemeClr val="accent1"/>
+          </a:lnRef>
+          <a:fillRef idx="3">
+            <a:schemeClr val="accent1"/>
+          </a:fillRef>
+          <a:effectRef idx="2">
+            <a:schemeClr val="accent1"/>
+          </a:effectRef>
+          <a:fontRef idx="minor">
+            <a:schemeClr val="lt1"/>
+          </a:fontRef>
+        </p:style>
+        <p:txBody>
+          <a:bodyPr rtlCol="0" anchor="ctr"/>
+          <a:lstStyle/>
+          <a:p>
+            <a:pPr algn="ctr"/>
+          </a:p>
+        </p:txBody>
+      </p:sp>
+      <p:sp>
+        <p:nvSpPr>
+          <p:cNvPr id="3" name="TextBox 2"/>
+          <p:cNvSpPr txBox="1"/>
+          <p:nvPr/>
+        </p:nvSpPr>
+        <p:spPr>
+          <a:xfrm>
+            <a:off x="685800" y="475488"/>
+            <a:ext cx="10820095" cy="914400"/>
+          </a:xfrm>
+          <a:prstGeom prst="rect">
+            <a:avLst/>
+          </a:prstGeom>
+          <a:noFill/>
+        </p:spPr>
+        <p:txBody>
+          <a:bodyPr wrap="square" anchor="t" lIns="0" rIns="0" tIns="0" bIns="0">
+            <a:spAutoFit/>
+          </a:bodyPr>
+          <a:lstStyle/>
+          <a:p>
+            <a:pPr algn="l">
+              <a:spcAft>
+                <a:spcPts val="0"/>
+              </a:spcAft>
+            </a:pPr>
+            <a:r>
+              <a:rPr sz="3200" b="1">
+                <a:solidFill>
+                  <a:srgbClr val="001552"/>
+                </a:solidFill>
+                <a:latin typeface="Cambria"/>
+              </a:rPr>
+              <a:t>Annex — the report this came from</a:t>
+            </a:r>
+          </a:p>
+        </p:txBody>
+      </p:sp>
+      <p:pic>
+        <p:nvPicPr>
+          <p:cNvPr id="4" name="Picture 3" descr="report-what-to-do.png"/>
+          <p:cNvPicPr>
+            <a:picLocks noChangeAspect="1"/>
+          </p:cNvPicPr>
+          <p:nvPr/>
+        </p:nvPicPr>
+        <p:blipFill>
+          <a:blip r:embed="rId2"/>
+          <a:stretch>
+            <a:fillRect/>
+          </a:stretch>
+        </p:blipFill>
+        <p:spPr>
+          <a:xfrm>
+            <a:off x="685800" y="1965960"/>
+            <a:ext cx="7223760" cy="4082995"/>
+          </a:xfrm>
+          <a:prstGeom prst="rect">
+            <a:avLst/>
+          </a:prstGeom>
+          <a:ln w="9525">
+            <a:solidFill>
+              <a:srgbClr val="E4E7EC"/>
+            </a:solidFill>
+          </a:ln>
+        </p:spPr>
+      </p:pic>
+      <p:sp>
+        <p:nvSpPr>
+          <p:cNvPr id="5" name="TextBox 4"/>
+          <p:cNvSpPr txBox="1"/>
+          <p:nvPr/>
+        </p:nvSpPr>
+        <p:spPr>
+          <a:xfrm>
+            <a:off x="8229600" y="1965960"/>
+            <a:ext cx="3291840" cy="3291840"/>
+          </a:xfrm>
+          <a:prstGeom prst="rect">
+            <a:avLst/>
+          </a:prstGeom>
+          <a:noFill/>
+        </p:spPr>
+        <p:txBody>
+          <a:bodyPr wrap="square" anchor="t" lIns="0" rIns="0" tIns="0" bIns="0">
+            <a:spAutoFit/>
+          </a:bodyPr>
+          <a:lstStyle/>
+          <a:p>
+            <a:pPr algn="l">
+              <a:spcAft>
+                <a:spcPts val="600"/>
+              </a:spcAft>
+            </a:pPr>
+            <a:r>
+              <a:rPr sz="1500" b="1">
+                <a:solidFill>
+                  <a:srgbClr val="001552"/>
+                </a:solidFill>
+                <a:latin typeface="Calibri"/>
+              </a:rPr>
+              <a:t>Four pages</a:t>
+            </a:r>
+          </a:p>
+          <a:p>
+            <a:pPr algn="l">
+              <a:spcAft>
+                <a:spcPts val="1000"/>
+              </a:spcAft>
+            </a:pPr>
+            <a:r>
+              <a:rPr sz="1200" b="0">
+                <a:solidFill>
+                  <a:srgbClr val="475467"/>
+                </a:solidFill>
+                <a:latin typeface="Calibri"/>
+              </a:rPr>
+              <a:t>Global Overview · Where the exposure is · The Scan · What to do.</a:t>
+            </a:r>
+          </a:p>
+          <a:p>
+            <a:pPr algn="l">
+              <a:spcAft>
+                <a:spcPts val="1400"/>
+              </a:spcAft>
+            </a:pPr>
+            <a:r>
+              <a:rPr sz="1200" b="0">
+                <a:solidFill>
+                  <a:srgbClr val="475467"/>
+                </a:solidFill>
+                <a:latin typeface="Calibri"/>
+              </a:rPr>
+              <a:t>Each carries an information panel stating what the page is for, which figures it shows, and what is deliberately left off it. The export page behind them is the contract a test suite reads.</a:t>
+            </a:r>
+          </a:p>
+          <a:p>
+            <a:pPr algn="l">
+              <a:spcAft>
+                <a:spcPts val="0"/>
+              </a:spcAft>
+            </a:pPr>
+            <a:r>
+              <a:rPr sz="1150" b="0">
+                <a:solidFill>
+                  <a:srgbClr val="667085"/>
+                </a:solidFill>
+                <a:latin typeface="Calibri"/>
+              </a:rPr>
+              <a:t>The screen shown is What to do — the fourth page, and the one this deck's recommendation is drawn from.</a:t>
+            </a:r>
+          </a:p>
+        </p:txBody>
+      </p:sp>
+      <p:sp>
+        <p:nvSpPr>
+          <p:cNvPr id="6" name="TextBox 5"/>
+          <p:cNvSpPr txBox="1"/>
+          <p:nvPr/>
+        </p:nvSpPr>
+        <p:spPr>
+          <a:xfrm>
+            <a:off x="8229600" y="5440680"/>
+            <a:ext cx="3291840" cy="274320"/>
+          </a:xfrm>
+          <a:prstGeom prst="rect">
+            <a:avLst/>
+          </a:prstGeom>
+          <a:noFill/>
+        </p:spPr>
+        <p:txBody>
+          <a:bodyPr wrap="square" lIns="0" rIns="0" tIns="0" bIns="0">
+            <a:spAutoFit/>
+          </a:bodyPr>
+          <a:lstStyle/>
+          <a:p>
+            <a:r>
+              <a:rPr sz="1200">
+                <a:solidFill>
+                  <a:srgbClr val="3E72C4"/>
+                </a:solidFill>
+                <a:latin typeface="Calibri"/>
+                <a:hlinkClick r:id="rId3"/>
+              </a:rPr>
+              <a:t>The repository</a:t>
+            </a:r>
+          </a:p>
+        </p:txBody>
+      </p:sp>
+      <p:sp>
+        <p:nvSpPr>
+          <p:cNvPr id="7" name="TextBox 6"/>
+          <p:cNvSpPr txBox="1"/>
+          <p:nvPr/>
+        </p:nvSpPr>
+        <p:spPr>
+          <a:xfrm>
+            <a:off x="8229600" y="5806440"/>
+            <a:ext cx="3291840" cy="274320"/>
+          </a:xfrm>
+          <a:prstGeom prst="rect">
+            <a:avLst/>
+          </a:prstGeom>
+          <a:noFill/>
+        </p:spPr>
+        <p:txBody>
+          <a:bodyPr wrap="square" lIns="0" rIns="0" tIns="0" bIns="0">
+            <a:spAutoFit/>
+          </a:bodyPr>
+          <a:lstStyle/>
+          <a:p>
+            <a:r>
+              <a:rPr sz="1200">
+                <a:solidFill>
+                  <a:srgbClr val="3E72C4"/>
+                </a:solidFill>
+                <a:latin typeface="Calibri"/>
+                <a:hlinkClick r:id="rId4"/>
+              </a:rPr>
+              <a:t>All four pages, with their panels (PDF)</a:t>
             </a:r>
           </a:p>
         </p:txBody>

</xml_diff>